<commit_message>
Rename TOL to tol_standard.xlsx, sanitize IPs/secrets, and update English README
</commit_message>
<xml_diff>
--- a/report_template_tr069.pptx
+++ b/report_template_tr069.pptx
@@ -3484,7 +3484,7 @@
                 </a:solidFill>
                 <a:latin typeface="TIM Sans" panose="02020503040602060503" pitchFamily="18" charset="0"/>
               </a:rPr>
-              <a:t>Gruppo TIM - Uso Interno - Tutti i diritti riservati.</a:t>
+              <a:t/>
             </a:r>
           </a:p>
         </p:txBody>
@@ -3917,7 +3917,7 @@
             </a:r>
             <a:r>
               <a:rPr dirty="0" err="1"/>
-              <a:t>ServerCri</a:t>
+              <a:t>Lab Server</a:t>
             </a:r>
             <a:r>
               <a:rPr dirty="0"/>
@@ -3980,7 +3980,7 @@
                   <a:srgbClr val="FFFF00"/>
                 </a:highlight>
               </a:rPr>
-              <a:t>Autore: Maria Cristina Rizzani</a:t>
+              <a:t>Autore: mcristina-git</a:t>
             </a:r>
           </a:p>
           <a:p>
@@ -4426,7 +4426,7 @@
               </a:defRPr>
             </a:pPr>
             <a:r>
-              <a:t>ServerCri ospita Kathara/Docker, GenieACS, MongoDB e il validator. La CPE comunica con l’ACS via CWMP.</a:t>
+              <a:t>Lab Server ospita Kathara/Docker, GenieACS, MongoDB e il validator. La CPE comunica con l’ACS via CWMP.</a:t>
             </a:r>
           </a:p>
         </p:txBody>
@@ -5368,7 +5368,7 @@
               </a:defRPr>
             </a:pPr>
             <a:r>
-              <a:t>Rete Kathara: collegamento esterno enp3s0, rete CPE e rete interna di gestione ACS–MongoDB.</a:t>
+              <a:t>Rete Kathara: collegamento esterno eth0, rete CPE e rete interna di gestione ACS–MongoDB.</a:t>
             </a:r>
           </a:p>
         </p:txBody>

</xml_diff>